<commit_message>
standard: theme_deck recurses into groups (fix grouped cards in B&W builds)
theme_deck.py now flattens group shapes with their transforms so grouped
content (e.g. the team-structure node cards) recolours correctly in the
light/dark builds; logo-wall groups (client logos, partner badges) are left
untouched so brand assets are preserved. Regenerated both single-theme decks.

https://claude.ai/code/session_013KakfoRwev8fSFVnXRjTeJ
</commit_message>
<xml_diff>
--- a/design-system/standard/Mivada_Standard_Dark.pptx
+++ b/design-system/standard/Mivada_Standard_Dark.pptx
@@ -27797,11 +27797,11 @@
               <a:avLst/>
             </a:prstGeom>
             <a:solidFill>
-              <a:srgbClr val="FFFFFF"/>
+              <a:srgbClr val="141414"/>
             </a:solidFill>
             <a:ln w="12700">
               <a:solidFill>
-                <a:srgbClr val="E4E4E0"/>
+                <a:srgbClr val="3A3A3A"/>
               </a:solidFill>
             </a:ln>
             <a:effectLst/>
@@ -27863,7 +27863,7 @@
               <a:r>
                 <a:rPr lang="en-AU" sz="1500" b="1" i="0" spc="-15">
                   <a:solidFill>
-                    <a:srgbClr val="111111"/>
+                    <a:srgbClr val="FFFFFF"/>
                   </a:solidFill>
                   <a:latin typeface="Inter"/>
                 </a:rPr>
@@ -27906,7 +27906,7 @@
               <a:r>
                 <a:rPr lang="en-AU" sz="1050" b="0" i="0" spc="0">
                   <a:solidFill>
-                    <a:srgbClr val="323232"/>
+                    <a:srgbClr val="CFCFCF"/>
                   </a:solidFill>
                   <a:latin typeface="Inter"/>
                 </a:rPr>
@@ -27951,11 +27951,11 @@
               <a:avLst/>
             </a:prstGeom>
             <a:solidFill>
-              <a:srgbClr val="FFFFFF"/>
+              <a:srgbClr val="141414"/>
             </a:solidFill>
             <a:ln w="12700">
               <a:solidFill>
-                <a:srgbClr val="E4E4E0"/>
+                <a:srgbClr val="3A3A3A"/>
               </a:solidFill>
             </a:ln>
             <a:effectLst/>
@@ -28017,7 +28017,7 @@
               <a:r>
                 <a:rPr lang="en-AU" sz="1500" b="1" i="0" spc="-15">
                   <a:solidFill>
-                    <a:srgbClr val="111111"/>
+                    <a:srgbClr val="FFFFFF"/>
                   </a:solidFill>
                   <a:latin typeface="Inter"/>
                 </a:rPr>
@@ -28060,7 +28060,7 @@
               <a:r>
                 <a:rPr lang="en-AU" sz="1050" b="0" i="0" spc="0">
                   <a:solidFill>
-                    <a:srgbClr val="323232"/>
+                    <a:srgbClr val="CFCFCF"/>
                   </a:solidFill>
                   <a:latin typeface="Inter"/>
                 </a:rPr>
@@ -28486,7 +28486,7 @@
               <a:srgbClr val="EA493F"/>
             </a:solidFill>
             <a:ln>
-              <a:noFill/>
+              <a:solidFill/>
             </a:ln>
             <a:effectLst/>
           </p:spPr>

</xml_diff>